<commit_message>
fix: ajustar titulo para nao sobrepor logo SENAI
- Reduzir largura da caixa de titulo de 9" para 7.8"
- Deixar espaco reservado (1.5") para logo SESI SENAI no canto superior direito
- Logo nao mais sobreposto pelo titulo
- Mantém legibilidade e padrão visual

Co-Authored-By: Claude Haiku 4.5 <noreply@anthropic.com>
</commit_message>
<xml_diff>
--- a/MATERIAIS/QUALIFICACAO-PROFISSIONAL/DIGITAL SKILLS/SlidesDigitalSkillsGemini.pptx
+++ b/MATERIAIS/QUALIFICACAO-PROFISSIONAL/DIGITAL SKILLS/SlidesDigitalSkillsGemini.pptx
@@ -3170,7 +3170,7 @@
         <p:spPr>
           <a:xfrm>
             <a:off x="457200" y="274320"/>
-            <a:ext cx="8229600" cy="914400"/>
+            <a:ext cx="7132320" cy="914400"/>
           </a:xfrm>
           <a:prstGeom prst="rect">
             <a:avLst/>
@@ -3260,7 +3260,7 @@
         <p:spPr>
           <a:xfrm>
             <a:off x="457200" y="274320"/>
-            <a:ext cx="8229600" cy="914400"/>
+            <a:ext cx="7132320" cy="914400"/>
           </a:xfrm>
           <a:prstGeom prst="rect">
             <a:avLst/>
@@ -3434,7 +3434,7 @@
         <p:spPr>
           <a:xfrm>
             <a:off x="457200" y="274320"/>
-            <a:ext cx="8229600" cy="914400"/>
+            <a:ext cx="7132320" cy="914400"/>
           </a:xfrm>
           <a:prstGeom prst="rect">
             <a:avLst/>
@@ -3524,7 +3524,7 @@
         <p:spPr>
           <a:xfrm>
             <a:off x="457200" y="274320"/>
-            <a:ext cx="8229600" cy="914400"/>
+            <a:ext cx="7132320" cy="914400"/>
           </a:xfrm>
           <a:prstGeom prst="rect">
             <a:avLst/>
@@ -3679,7 +3679,7 @@
         <p:spPr>
           <a:xfrm>
             <a:off x="457200" y="274320"/>
-            <a:ext cx="8229600" cy="914400"/>
+            <a:ext cx="7132320" cy="914400"/>
           </a:xfrm>
           <a:prstGeom prst="rect">
             <a:avLst/>
@@ -3769,7 +3769,7 @@
         <p:spPr>
           <a:xfrm>
             <a:off x="457200" y="274320"/>
-            <a:ext cx="8229600" cy="914400"/>
+            <a:ext cx="7132320" cy="914400"/>
           </a:xfrm>
           <a:prstGeom prst="rect">
             <a:avLst/>
@@ -3962,7 +3962,7 @@
         <p:spPr>
           <a:xfrm>
             <a:off x="457200" y="274320"/>
-            <a:ext cx="8229600" cy="914400"/>
+            <a:ext cx="7132320" cy="914400"/>
           </a:xfrm>
           <a:prstGeom prst="rect">
             <a:avLst/>
@@ -4052,7 +4052,7 @@
         <p:spPr>
           <a:xfrm>
             <a:off x="457200" y="274320"/>
-            <a:ext cx="8229600" cy="914400"/>
+            <a:ext cx="7132320" cy="914400"/>
           </a:xfrm>
           <a:prstGeom prst="rect">
             <a:avLst/>
@@ -4245,7 +4245,7 @@
         <p:spPr>
           <a:xfrm>
             <a:off x="457200" y="274320"/>
-            <a:ext cx="8229600" cy="914400"/>
+            <a:ext cx="7132320" cy="914400"/>
           </a:xfrm>
           <a:prstGeom prst="rect">
             <a:avLst/>
@@ -4335,7 +4335,7 @@
         <p:spPr>
           <a:xfrm>
             <a:off x="457200" y="274320"/>
-            <a:ext cx="8229600" cy="914400"/>
+            <a:ext cx="7132320" cy="914400"/>
           </a:xfrm>
           <a:prstGeom prst="rect">
             <a:avLst/>
@@ -4509,7 +4509,7 @@
         <p:spPr>
           <a:xfrm>
             <a:off x="457200" y="274320"/>
-            <a:ext cx="8229600" cy="914400"/>
+            <a:ext cx="7132320" cy="914400"/>
           </a:xfrm>
           <a:prstGeom prst="rect">
             <a:avLst/>
@@ -4599,7 +4599,7 @@
         <p:spPr>
           <a:xfrm>
             <a:off x="457200" y="274320"/>
-            <a:ext cx="8229600" cy="914400"/>
+            <a:ext cx="7132320" cy="914400"/>
           </a:xfrm>
           <a:prstGeom prst="rect">
             <a:avLst/>
@@ -4773,7 +4773,7 @@
         <p:spPr>
           <a:xfrm>
             <a:off x="457200" y="274320"/>
-            <a:ext cx="8229600" cy="914400"/>
+            <a:ext cx="7132320" cy="914400"/>
           </a:xfrm>
           <a:prstGeom prst="rect">
             <a:avLst/>
@@ -4863,7 +4863,7 @@
         <p:spPr>
           <a:xfrm>
             <a:off x="457200" y="274320"/>
-            <a:ext cx="8229600" cy="914400"/>
+            <a:ext cx="7132320" cy="914400"/>
           </a:xfrm>
           <a:prstGeom prst="rect">
             <a:avLst/>
@@ -4983,7 +4983,7 @@
         <p:spPr>
           <a:xfrm>
             <a:off x="457200" y="274320"/>
-            <a:ext cx="8229600" cy="914400"/>
+            <a:ext cx="7132320" cy="914400"/>
           </a:xfrm>
           <a:prstGeom prst="rect">
             <a:avLst/>
@@ -5073,7 +5073,7 @@
         <p:spPr>
           <a:xfrm>
             <a:off x="457200" y="274320"/>
-            <a:ext cx="8229600" cy="914400"/>
+            <a:ext cx="7132320" cy="914400"/>
           </a:xfrm>
           <a:prstGeom prst="rect">
             <a:avLst/>
@@ -5407,7 +5407,7 @@
         <p:spPr>
           <a:xfrm>
             <a:off x="457200" y="274320"/>
-            <a:ext cx="8229600" cy="914400"/>
+            <a:ext cx="7132320" cy="914400"/>
           </a:xfrm>
           <a:prstGeom prst="rect">
             <a:avLst/>
@@ -5497,7 +5497,7 @@
         <p:spPr>
           <a:xfrm>
             <a:off x="457200" y="274320"/>
-            <a:ext cx="8229600" cy="914400"/>
+            <a:ext cx="7132320" cy="914400"/>
           </a:xfrm>
           <a:prstGeom prst="rect">
             <a:avLst/>
@@ -5652,7 +5652,7 @@
         <p:spPr>
           <a:xfrm>
             <a:off x="457200" y="274320"/>
-            <a:ext cx="8229600" cy="914400"/>
+            <a:ext cx="7132320" cy="914400"/>
           </a:xfrm>
           <a:prstGeom prst="rect">
             <a:avLst/>
@@ -5742,7 +5742,7 @@
         <p:spPr>
           <a:xfrm>
             <a:off x="457200" y="274320"/>
-            <a:ext cx="8229600" cy="914400"/>
+            <a:ext cx="7132320" cy="914400"/>
           </a:xfrm>
           <a:prstGeom prst="rect">
             <a:avLst/>
@@ -5862,7 +5862,7 @@
         <p:spPr>
           <a:xfrm>
             <a:off x="457200" y="274320"/>
-            <a:ext cx="8229600" cy="914400"/>
+            <a:ext cx="7132320" cy="914400"/>
           </a:xfrm>
           <a:prstGeom prst="rect">
             <a:avLst/>
@@ -5952,7 +5952,7 @@
         <p:spPr>
           <a:xfrm>
             <a:off x="457200" y="274320"/>
-            <a:ext cx="8229600" cy="914400"/>
+            <a:ext cx="7132320" cy="914400"/>
           </a:xfrm>
           <a:prstGeom prst="rect">
             <a:avLst/>
@@ -6054,7 +6054,7 @@
         <p:spPr>
           <a:xfrm>
             <a:off x="457200" y="274320"/>
-            <a:ext cx="8229600" cy="914400"/>
+            <a:ext cx="7132320" cy="914400"/>
           </a:xfrm>
           <a:prstGeom prst="rect">
             <a:avLst/>
@@ -6144,7 +6144,7 @@
         <p:spPr>
           <a:xfrm>
             <a:off x="457200" y="274320"/>
-            <a:ext cx="8229600" cy="914400"/>
+            <a:ext cx="7132320" cy="914400"/>
           </a:xfrm>
           <a:prstGeom prst="rect">
             <a:avLst/>
@@ -6246,7 +6246,7 @@
         <p:spPr>
           <a:xfrm>
             <a:off x="457200" y="274320"/>
-            <a:ext cx="8229600" cy="914400"/>
+            <a:ext cx="7132320" cy="914400"/>
           </a:xfrm>
           <a:prstGeom prst="rect">
             <a:avLst/>
@@ -6336,7 +6336,7 @@
         <p:spPr>
           <a:xfrm>
             <a:off x="457200" y="274320"/>
-            <a:ext cx="8229600" cy="914400"/>
+            <a:ext cx="7132320" cy="914400"/>
           </a:xfrm>
           <a:prstGeom prst="rect">
             <a:avLst/>
@@ -6438,7 +6438,7 @@
         <p:spPr>
           <a:xfrm>
             <a:off x="457200" y="274320"/>
-            <a:ext cx="8229600" cy="914400"/>
+            <a:ext cx="7132320" cy="914400"/>
           </a:xfrm>
           <a:prstGeom prst="rect">
             <a:avLst/>
@@ -6528,7 +6528,7 @@
         <p:spPr>
           <a:xfrm>
             <a:off x="457200" y="274320"/>
-            <a:ext cx="8229600" cy="914400"/>
+            <a:ext cx="7132320" cy="914400"/>
           </a:xfrm>
           <a:prstGeom prst="rect">
             <a:avLst/>
@@ -6740,7 +6740,7 @@
         <p:spPr>
           <a:xfrm>
             <a:off x="457200" y="274320"/>
-            <a:ext cx="8229600" cy="914400"/>
+            <a:ext cx="7132320" cy="914400"/>
           </a:xfrm>
           <a:prstGeom prst="rect">
             <a:avLst/>
@@ -6830,7 +6830,7 @@
         <p:spPr>
           <a:xfrm>
             <a:off x="457200" y="274320"/>
-            <a:ext cx="8229600" cy="914400"/>
+            <a:ext cx="7132320" cy="914400"/>
           </a:xfrm>
           <a:prstGeom prst="rect">
             <a:avLst/>
@@ -6932,7 +6932,7 @@
         <p:spPr>
           <a:xfrm>
             <a:off x="457200" y="274320"/>
-            <a:ext cx="8229600" cy="914400"/>
+            <a:ext cx="7132320" cy="914400"/>
           </a:xfrm>
           <a:prstGeom prst="rect">
             <a:avLst/>
@@ -7022,7 +7022,7 @@
         <p:spPr>
           <a:xfrm>
             <a:off x="457200" y="274320"/>
-            <a:ext cx="8229600" cy="914400"/>
+            <a:ext cx="7132320" cy="914400"/>
           </a:xfrm>
           <a:prstGeom prst="rect">
             <a:avLst/>
@@ -7142,7 +7142,7 @@
         <p:spPr>
           <a:xfrm>
             <a:off x="457200" y="274320"/>
-            <a:ext cx="8229600" cy="914400"/>
+            <a:ext cx="7132320" cy="914400"/>
           </a:xfrm>
           <a:prstGeom prst="rect">
             <a:avLst/>
@@ -7232,7 +7232,7 @@
         <p:spPr>
           <a:xfrm>
             <a:off x="457200" y="274320"/>
-            <a:ext cx="8229600" cy="914400"/>
+            <a:ext cx="7132320" cy="914400"/>
           </a:xfrm>
           <a:prstGeom prst="rect">
             <a:avLst/>
@@ -7536,7 +7536,7 @@
         <p:spPr>
           <a:xfrm>
             <a:off x="457200" y="274320"/>
-            <a:ext cx="8229600" cy="914400"/>
+            <a:ext cx="7132320" cy="914400"/>
           </a:xfrm>
           <a:prstGeom prst="rect">
             <a:avLst/>
@@ -7626,7 +7626,7 @@
         <p:spPr>
           <a:xfrm>
             <a:off x="457200" y="274320"/>
-            <a:ext cx="8229600" cy="914400"/>
+            <a:ext cx="7132320" cy="914400"/>
           </a:xfrm>
           <a:prstGeom prst="rect">
             <a:avLst/>
@@ -7838,7 +7838,7 @@
         <p:spPr>
           <a:xfrm>
             <a:off x="457200" y="274320"/>
-            <a:ext cx="8229600" cy="914400"/>
+            <a:ext cx="7132320" cy="914400"/>
           </a:xfrm>
           <a:prstGeom prst="rect">
             <a:avLst/>
@@ -7928,7 +7928,7 @@
         <p:spPr>
           <a:xfrm>
             <a:off x="457200" y="274320"/>
-            <a:ext cx="8229600" cy="914400"/>
+            <a:ext cx="7132320" cy="914400"/>
           </a:xfrm>
           <a:prstGeom prst="rect">
             <a:avLst/>
@@ -8302,7 +8302,7 @@
         <p:spPr>
           <a:xfrm>
             <a:off x="457200" y="274320"/>
-            <a:ext cx="8229600" cy="914400"/>
+            <a:ext cx="7132320" cy="914400"/>
           </a:xfrm>
           <a:prstGeom prst="rect">
             <a:avLst/>
@@ -8392,7 +8392,7 @@
         <p:spPr>
           <a:xfrm>
             <a:off x="457200" y="274320"/>
-            <a:ext cx="8229600" cy="914400"/>
+            <a:ext cx="7132320" cy="914400"/>
           </a:xfrm>
           <a:prstGeom prst="rect">
             <a:avLst/>
@@ -8760,7 +8760,7 @@
         <p:spPr>
           <a:xfrm>
             <a:off x="457200" y="274320"/>
-            <a:ext cx="8229600" cy="914400"/>
+            <a:ext cx="7132320" cy="914400"/>
           </a:xfrm>
           <a:prstGeom prst="rect">
             <a:avLst/>
@@ -8850,7 +8850,7 @@
         <p:spPr>
           <a:xfrm>
             <a:off x="457200" y="274320"/>
-            <a:ext cx="8229600" cy="914400"/>
+            <a:ext cx="7132320" cy="914400"/>
           </a:xfrm>
           <a:prstGeom prst="rect">
             <a:avLst/>
@@ -8952,7 +8952,7 @@
         <p:spPr>
           <a:xfrm>
             <a:off x="457200" y="274320"/>
-            <a:ext cx="8229600" cy="914400"/>
+            <a:ext cx="7132320" cy="914400"/>
           </a:xfrm>
           <a:prstGeom prst="rect">
             <a:avLst/>
@@ -9042,7 +9042,7 @@
         <p:spPr>
           <a:xfrm>
             <a:off x="457200" y="274320"/>
-            <a:ext cx="8229600" cy="914400"/>
+            <a:ext cx="7132320" cy="914400"/>
           </a:xfrm>
           <a:prstGeom prst="rect">
             <a:avLst/>
@@ -9162,7 +9162,7 @@
         <p:spPr>
           <a:xfrm>
             <a:off x="457200" y="274320"/>
-            <a:ext cx="8229600" cy="914400"/>
+            <a:ext cx="7132320" cy="914400"/>
           </a:xfrm>
           <a:prstGeom prst="rect">
             <a:avLst/>
@@ -9252,7 +9252,7 @@
         <p:spPr>
           <a:xfrm>
             <a:off x="457200" y="274320"/>
-            <a:ext cx="8229600" cy="914400"/>
+            <a:ext cx="7132320" cy="914400"/>
           </a:xfrm>
           <a:prstGeom prst="rect">
             <a:avLst/>
@@ -9372,7 +9372,7 @@
         <p:spPr>
           <a:xfrm>
             <a:off x="457200" y="274320"/>
-            <a:ext cx="8229600" cy="914400"/>
+            <a:ext cx="7132320" cy="914400"/>
           </a:xfrm>
           <a:prstGeom prst="rect">
             <a:avLst/>
@@ -9462,7 +9462,7 @@
         <p:spPr>
           <a:xfrm>
             <a:off x="457200" y="274320"/>
-            <a:ext cx="8229600" cy="914400"/>
+            <a:ext cx="7132320" cy="914400"/>
           </a:xfrm>
           <a:prstGeom prst="rect">
             <a:avLst/>
@@ -9617,7 +9617,7 @@
         <p:spPr>
           <a:xfrm>
             <a:off x="457200" y="274320"/>
-            <a:ext cx="8229600" cy="914400"/>
+            <a:ext cx="7132320" cy="914400"/>
           </a:xfrm>
           <a:prstGeom prst="rect">
             <a:avLst/>
@@ -9707,7 +9707,7 @@
         <p:spPr>
           <a:xfrm>
             <a:off x="457200" y="274320"/>
-            <a:ext cx="8229600" cy="914400"/>
+            <a:ext cx="7132320" cy="914400"/>
           </a:xfrm>
           <a:prstGeom prst="rect">
             <a:avLst/>
@@ -9973,7 +9973,7 @@
         <p:spPr>
           <a:xfrm>
             <a:off x="457200" y="274320"/>
-            <a:ext cx="8229600" cy="914400"/>
+            <a:ext cx="7132320" cy="914400"/>
           </a:xfrm>
           <a:prstGeom prst="rect">
             <a:avLst/>
@@ -10063,7 +10063,7 @@
         <p:spPr>
           <a:xfrm>
             <a:off x="457200" y="274320"/>
-            <a:ext cx="8229600" cy="914400"/>
+            <a:ext cx="7132320" cy="914400"/>
           </a:xfrm>
           <a:prstGeom prst="rect">
             <a:avLst/>
@@ -10218,7 +10218,7 @@
         <p:spPr>
           <a:xfrm>
             <a:off x="457200" y="274320"/>
-            <a:ext cx="8229600" cy="914400"/>
+            <a:ext cx="7132320" cy="914400"/>
           </a:xfrm>
           <a:prstGeom prst="rect">
             <a:avLst/>
@@ -10308,7 +10308,7 @@
         <p:spPr>
           <a:xfrm>
             <a:off x="457200" y="274320"/>
-            <a:ext cx="8229600" cy="914400"/>
+            <a:ext cx="7132320" cy="914400"/>
           </a:xfrm>
           <a:prstGeom prst="rect">
             <a:avLst/>
@@ -10805,7 +10805,7 @@
         <p:spPr>
           <a:xfrm>
             <a:off x="457200" y="274320"/>
-            <a:ext cx="8229600" cy="914400"/>
+            <a:ext cx="7132320" cy="914400"/>
           </a:xfrm>
           <a:prstGeom prst="rect">
             <a:avLst/>
@@ -10895,7 +10895,7 @@
         <p:spPr>
           <a:xfrm>
             <a:off x="457200" y="274320"/>
-            <a:ext cx="8229600" cy="914400"/>
+            <a:ext cx="7132320" cy="914400"/>
           </a:xfrm>
           <a:prstGeom prst="rect">
             <a:avLst/>
@@ -11050,7 +11050,7 @@
         <p:spPr>
           <a:xfrm>
             <a:off x="457200" y="274320"/>
-            <a:ext cx="8229600" cy="914400"/>
+            <a:ext cx="7132320" cy="914400"/>
           </a:xfrm>
           <a:prstGeom prst="rect">
             <a:avLst/>
@@ -11140,7 +11140,7 @@
         <p:spPr>
           <a:xfrm>
             <a:off x="457200" y="274320"/>
-            <a:ext cx="8229600" cy="914400"/>
+            <a:ext cx="7132320" cy="914400"/>
           </a:xfrm>
           <a:prstGeom prst="rect">
             <a:avLst/>
@@ -11260,7 +11260,7 @@
         <p:spPr>
           <a:xfrm>
             <a:off x="457200" y="274320"/>
-            <a:ext cx="8229600" cy="914400"/>
+            <a:ext cx="7132320" cy="914400"/>
           </a:xfrm>
           <a:prstGeom prst="rect">
             <a:avLst/>
@@ -11350,7 +11350,7 @@
         <p:spPr>
           <a:xfrm>
             <a:off x="457200" y="274320"/>
-            <a:ext cx="8229600" cy="914400"/>
+            <a:ext cx="7132320" cy="914400"/>
           </a:xfrm>
           <a:prstGeom prst="rect">
             <a:avLst/>
@@ -11600,7 +11600,7 @@
         <p:spPr>
           <a:xfrm>
             <a:off x="457200" y="274320"/>
-            <a:ext cx="8229600" cy="914400"/>
+            <a:ext cx="7132320" cy="914400"/>
           </a:xfrm>
           <a:prstGeom prst="rect">
             <a:avLst/>
@@ -11690,7 +11690,7 @@
         <p:spPr>
           <a:xfrm>
             <a:off x="457200" y="274320"/>
-            <a:ext cx="8229600" cy="914400"/>
+            <a:ext cx="7132320" cy="914400"/>
           </a:xfrm>
           <a:prstGeom prst="rect">
             <a:avLst/>
@@ -13177,7 +13177,7 @@
         <p:spPr>
           <a:xfrm>
             <a:off x="457200" y="274320"/>
-            <a:ext cx="8229600" cy="914400"/>
+            <a:ext cx="7132320" cy="914400"/>
           </a:xfrm>
           <a:prstGeom prst="rect">
             <a:avLst/>
@@ -13267,7 +13267,7 @@
         <p:spPr>
           <a:xfrm>
             <a:off x="457200" y="274320"/>
-            <a:ext cx="8229600" cy="914400"/>
+            <a:ext cx="7132320" cy="914400"/>
           </a:xfrm>
           <a:prstGeom prst="rect">
             <a:avLst/>
@@ -13460,7 +13460,7 @@
         <p:spPr>
           <a:xfrm>
             <a:off x="457200" y="274320"/>
-            <a:ext cx="8229600" cy="914400"/>
+            <a:ext cx="7132320" cy="914400"/>
           </a:xfrm>
           <a:prstGeom prst="rect">
             <a:avLst/>
@@ -13550,7 +13550,7 @@
         <p:spPr>
           <a:xfrm>
             <a:off x="457200" y="274320"/>
-            <a:ext cx="8229600" cy="914400"/>
+            <a:ext cx="7132320" cy="914400"/>
           </a:xfrm>
           <a:prstGeom prst="rect">
             <a:avLst/>
@@ -13838,7 +13838,7 @@
         <p:spPr>
           <a:xfrm>
             <a:off x="457200" y="274320"/>
-            <a:ext cx="8229600" cy="914400"/>
+            <a:ext cx="7132320" cy="914400"/>
           </a:xfrm>
           <a:prstGeom prst="rect">
             <a:avLst/>
@@ -13928,7 +13928,7 @@
         <p:spPr>
           <a:xfrm>
             <a:off x="457200" y="274320"/>
-            <a:ext cx="8229600" cy="914400"/>
+            <a:ext cx="7132320" cy="914400"/>
           </a:xfrm>
           <a:prstGeom prst="rect">
             <a:avLst/>
@@ -14325,7 +14325,7 @@
         <p:spPr>
           <a:xfrm>
             <a:off x="457200" y="274320"/>
-            <a:ext cx="8229600" cy="914400"/>
+            <a:ext cx="7132320" cy="914400"/>
           </a:xfrm>
           <a:prstGeom prst="rect">
             <a:avLst/>
@@ -14415,7 +14415,7 @@
         <p:spPr>
           <a:xfrm>
             <a:off x="457200" y="274320"/>
-            <a:ext cx="8229600" cy="914400"/>
+            <a:ext cx="7132320" cy="914400"/>
           </a:xfrm>
           <a:prstGeom prst="rect">
             <a:avLst/>
@@ -15984,7 +15984,7 @@
         <p:spPr>
           <a:xfrm>
             <a:off x="457200" y="274320"/>
-            <a:ext cx="8229600" cy="914400"/>
+            <a:ext cx="7132320" cy="914400"/>
           </a:xfrm>
           <a:prstGeom prst="rect">
             <a:avLst/>
@@ -16074,7 +16074,7 @@
         <p:spPr>
           <a:xfrm>
             <a:off x="457200" y="274320"/>
-            <a:ext cx="8229600" cy="914400"/>
+            <a:ext cx="7132320" cy="914400"/>
           </a:xfrm>
           <a:prstGeom prst="rect">
             <a:avLst/>
@@ -16359,7 +16359,7 @@
         <p:spPr>
           <a:xfrm>
             <a:off x="457200" y="274320"/>
-            <a:ext cx="8229600" cy="914400"/>
+            <a:ext cx="7132320" cy="914400"/>
           </a:xfrm>
           <a:prstGeom prst="rect">
             <a:avLst/>
@@ -16449,7 +16449,7 @@
         <p:spPr>
           <a:xfrm>
             <a:off x="457200" y="274320"/>
-            <a:ext cx="8229600" cy="914400"/>
+            <a:ext cx="7132320" cy="914400"/>
           </a:xfrm>
           <a:prstGeom prst="rect">
             <a:avLst/>
@@ -16972,7 +16972,7 @@
         <p:spPr>
           <a:xfrm>
             <a:off x="457200" y="274320"/>
-            <a:ext cx="8229600" cy="914400"/>
+            <a:ext cx="7132320" cy="914400"/>
           </a:xfrm>
           <a:prstGeom prst="rect">
             <a:avLst/>
@@ -17062,7 +17062,7 @@
         <p:spPr>
           <a:xfrm>
             <a:off x="457200" y="274320"/>
-            <a:ext cx="8229600" cy="914400"/>
+            <a:ext cx="7132320" cy="914400"/>
           </a:xfrm>
           <a:prstGeom prst="rect">
             <a:avLst/>
@@ -18516,7 +18516,7 @@
         <p:spPr>
           <a:xfrm>
             <a:off x="457200" y="274320"/>
-            <a:ext cx="8229600" cy="914400"/>
+            <a:ext cx="7132320" cy="914400"/>
           </a:xfrm>
           <a:prstGeom prst="rect">
             <a:avLst/>
@@ -18606,7 +18606,7 @@
         <p:spPr>
           <a:xfrm>
             <a:off x="457200" y="274320"/>
-            <a:ext cx="8229600" cy="914400"/>
+            <a:ext cx="7132320" cy="914400"/>
           </a:xfrm>
           <a:prstGeom prst="rect">
             <a:avLst/>
@@ -18708,7 +18708,7 @@
         <p:spPr>
           <a:xfrm>
             <a:off x="457200" y="274320"/>
-            <a:ext cx="8229600" cy="914400"/>
+            <a:ext cx="7132320" cy="914400"/>
           </a:xfrm>
           <a:prstGeom prst="rect">
             <a:avLst/>
@@ -18798,7 +18798,7 @@
         <p:spPr>
           <a:xfrm>
             <a:off x="457200" y="274320"/>
-            <a:ext cx="8229600" cy="914400"/>
+            <a:ext cx="7132320" cy="914400"/>
           </a:xfrm>
           <a:prstGeom prst="rect">
             <a:avLst/>
@@ -18900,7 +18900,7 @@
         <p:spPr>
           <a:xfrm>
             <a:off x="457200" y="274320"/>
-            <a:ext cx="8229600" cy="914400"/>
+            <a:ext cx="7132320" cy="914400"/>
           </a:xfrm>
           <a:prstGeom prst="rect">
             <a:avLst/>
@@ -18990,7 +18990,7 @@
         <p:spPr>
           <a:xfrm>
             <a:off x="457200" y="274320"/>
-            <a:ext cx="8229600" cy="914400"/>
+            <a:ext cx="7132320" cy="914400"/>
           </a:xfrm>
           <a:prstGeom prst="rect">
             <a:avLst/>
@@ -19092,7 +19092,7 @@
         <p:spPr>
           <a:xfrm>
             <a:off x="457200" y="274320"/>
-            <a:ext cx="8229600" cy="914400"/>
+            <a:ext cx="7132320" cy="914400"/>
           </a:xfrm>
           <a:prstGeom prst="rect">
             <a:avLst/>
@@ -19182,7 +19182,7 @@
         <p:spPr>
           <a:xfrm>
             <a:off x="457200" y="274320"/>
-            <a:ext cx="8229600" cy="914400"/>
+            <a:ext cx="7132320" cy="914400"/>
           </a:xfrm>
           <a:prstGeom prst="rect">
             <a:avLst/>
@@ -20208,7 +20208,7 @@
         <p:spPr>
           <a:xfrm>
             <a:off x="457200" y="274320"/>
-            <a:ext cx="8229600" cy="914400"/>
+            <a:ext cx="7132320" cy="914400"/>
           </a:xfrm>
           <a:prstGeom prst="rect">
             <a:avLst/>
@@ -20298,7 +20298,7 @@
         <p:spPr>
           <a:xfrm>
             <a:off x="457200" y="274320"/>
-            <a:ext cx="8229600" cy="914400"/>
+            <a:ext cx="7132320" cy="914400"/>
           </a:xfrm>
           <a:prstGeom prst="rect">
             <a:avLst/>
@@ -20453,7 +20453,7 @@
         <p:spPr>
           <a:xfrm>
             <a:off x="457200" y="274320"/>
-            <a:ext cx="8229600" cy="914400"/>
+            <a:ext cx="7132320" cy="914400"/>
           </a:xfrm>
           <a:prstGeom prst="rect">
             <a:avLst/>
@@ -20543,7 +20543,7 @@
         <p:spPr>
           <a:xfrm>
             <a:off x="457200" y="274320"/>
-            <a:ext cx="8229600" cy="914400"/>
+            <a:ext cx="7132320" cy="914400"/>
           </a:xfrm>
           <a:prstGeom prst="rect">
             <a:avLst/>
@@ -20645,7 +20645,7 @@
         <p:spPr>
           <a:xfrm>
             <a:off x="457200" y="274320"/>
-            <a:ext cx="8229600" cy="914400"/>
+            <a:ext cx="7132320" cy="914400"/>
           </a:xfrm>
           <a:prstGeom prst="rect">
             <a:avLst/>
@@ -20735,7 +20735,7 @@
         <p:spPr>
           <a:xfrm>
             <a:off x="457200" y="274320"/>
-            <a:ext cx="8229600" cy="914400"/>
+            <a:ext cx="7132320" cy="914400"/>
           </a:xfrm>
           <a:prstGeom prst="rect">
             <a:avLst/>
@@ -21100,7 +21100,7 @@
         <p:spPr>
           <a:xfrm>
             <a:off x="457200" y="274320"/>
-            <a:ext cx="8229600" cy="914400"/>
+            <a:ext cx="7132320" cy="914400"/>
           </a:xfrm>
           <a:prstGeom prst="rect">
             <a:avLst/>
@@ -21190,7 +21190,7 @@
         <p:spPr>
           <a:xfrm>
             <a:off x="457200" y="274320"/>
-            <a:ext cx="8229600" cy="914400"/>
+            <a:ext cx="7132320" cy="914400"/>
           </a:xfrm>
           <a:prstGeom prst="rect">
             <a:avLst/>
@@ -22889,7 +22889,7 @@
         <p:spPr>
           <a:xfrm>
             <a:off x="457200" y="274320"/>
-            <a:ext cx="8229600" cy="914400"/>
+            <a:ext cx="7132320" cy="914400"/>
           </a:xfrm>
           <a:prstGeom prst="rect">
             <a:avLst/>
@@ -22979,7 +22979,7 @@
         <p:spPr>
           <a:xfrm>
             <a:off x="457200" y="274320"/>
-            <a:ext cx="8229600" cy="914400"/>
+            <a:ext cx="7132320" cy="914400"/>
           </a:xfrm>
           <a:prstGeom prst="rect">
             <a:avLst/>
@@ -23169,7 +23169,7 @@
         <p:spPr>
           <a:xfrm>
             <a:off x="457200" y="274320"/>
-            <a:ext cx="8229600" cy="914400"/>
+            <a:ext cx="7132320" cy="914400"/>
           </a:xfrm>
           <a:prstGeom prst="rect">
             <a:avLst/>
@@ -23259,7 +23259,7 @@
         <p:spPr>
           <a:xfrm>
             <a:off x="457200" y="274320"/>
-            <a:ext cx="8229600" cy="914400"/>
+            <a:ext cx="7132320" cy="914400"/>
           </a:xfrm>
           <a:prstGeom prst="rect">
             <a:avLst/>
@@ -23361,7 +23361,7 @@
         <p:spPr>
           <a:xfrm>
             <a:off x="457200" y="274320"/>
-            <a:ext cx="8229600" cy="914400"/>
+            <a:ext cx="7132320" cy="914400"/>
           </a:xfrm>
           <a:prstGeom prst="rect">
             <a:avLst/>
@@ -23451,7 +23451,7 @@
         <p:spPr>
           <a:xfrm>
             <a:off x="457200" y="274320"/>
-            <a:ext cx="8229600" cy="914400"/>
+            <a:ext cx="7132320" cy="914400"/>
           </a:xfrm>
           <a:prstGeom prst="rect">
             <a:avLst/>
@@ -23606,7 +23606,7 @@
         <p:spPr>
           <a:xfrm>
             <a:off x="457200" y="274320"/>
-            <a:ext cx="8229600" cy="914400"/>
+            <a:ext cx="7132320" cy="914400"/>
           </a:xfrm>
           <a:prstGeom prst="rect">
             <a:avLst/>
@@ -23696,7 +23696,7 @@
         <p:spPr>
           <a:xfrm>
             <a:off x="457200" y="274320"/>
-            <a:ext cx="8229600" cy="914400"/>
+            <a:ext cx="7132320" cy="914400"/>
           </a:xfrm>
           <a:prstGeom prst="rect">
             <a:avLst/>

</xml_diff>

<commit_message>
fix: aumentar espaco reservado para logo SENAI - 7.0 polegadas
- Reduzir largura da caixa de titulo para 7.0"
- Deixar espaco amplo (3 polegadas) para logo SESI SENAI
- Logo completamente visivel, sem sobrecarga
- Titulo mantém legibilidade com 7" de espaço

Co-Authored-By: Claude Haiku 4.5 <noreply@anthropic.com>
</commit_message>
<xml_diff>
--- a/MATERIAIS/QUALIFICACAO-PROFISSIONAL/DIGITAL SKILLS/SlidesDigitalSkillsGemini.pptx
+++ b/MATERIAIS/QUALIFICACAO-PROFISSIONAL/DIGITAL SKILLS/SlidesDigitalSkillsGemini.pptx
@@ -3170,7 +3170,7 @@
         <p:spPr>
           <a:xfrm>
             <a:off x="457200" y="274320"/>
-            <a:ext cx="7132320" cy="914400"/>
+            <a:ext cx="6400800" cy="914400"/>
           </a:xfrm>
           <a:prstGeom prst="rect">
             <a:avLst/>
@@ -3260,7 +3260,7 @@
         <p:spPr>
           <a:xfrm>
             <a:off x="457200" y="274320"/>
-            <a:ext cx="7132320" cy="914400"/>
+            <a:ext cx="6400800" cy="914400"/>
           </a:xfrm>
           <a:prstGeom prst="rect">
             <a:avLst/>
@@ -3434,7 +3434,7 @@
         <p:spPr>
           <a:xfrm>
             <a:off x="457200" y="274320"/>
-            <a:ext cx="7132320" cy="914400"/>
+            <a:ext cx="6400800" cy="914400"/>
           </a:xfrm>
           <a:prstGeom prst="rect">
             <a:avLst/>
@@ -3524,7 +3524,7 @@
         <p:spPr>
           <a:xfrm>
             <a:off x="457200" y="274320"/>
-            <a:ext cx="7132320" cy="914400"/>
+            <a:ext cx="6400800" cy="914400"/>
           </a:xfrm>
           <a:prstGeom prst="rect">
             <a:avLst/>
@@ -3679,7 +3679,7 @@
         <p:spPr>
           <a:xfrm>
             <a:off x="457200" y="274320"/>
-            <a:ext cx="7132320" cy="914400"/>
+            <a:ext cx="6400800" cy="914400"/>
           </a:xfrm>
           <a:prstGeom prst="rect">
             <a:avLst/>
@@ -3769,7 +3769,7 @@
         <p:spPr>
           <a:xfrm>
             <a:off x="457200" y="274320"/>
-            <a:ext cx="7132320" cy="914400"/>
+            <a:ext cx="6400800" cy="914400"/>
           </a:xfrm>
           <a:prstGeom prst="rect">
             <a:avLst/>
@@ -3962,7 +3962,7 @@
         <p:spPr>
           <a:xfrm>
             <a:off x="457200" y="274320"/>
-            <a:ext cx="7132320" cy="914400"/>
+            <a:ext cx="6400800" cy="914400"/>
           </a:xfrm>
           <a:prstGeom prst="rect">
             <a:avLst/>
@@ -4052,7 +4052,7 @@
         <p:spPr>
           <a:xfrm>
             <a:off x="457200" y="274320"/>
-            <a:ext cx="7132320" cy="914400"/>
+            <a:ext cx="6400800" cy="914400"/>
           </a:xfrm>
           <a:prstGeom prst="rect">
             <a:avLst/>
@@ -4245,7 +4245,7 @@
         <p:spPr>
           <a:xfrm>
             <a:off x="457200" y="274320"/>
-            <a:ext cx="7132320" cy="914400"/>
+            <a:ext cx="6400800" cy="914400"/>
           </a:xfrm>
           <a:prstGeom prst="rect">
             <a:avLst/>
@@ -4335,7 +4335,7 @@
         <p:spPr>
           <a:xfrm>
             <a:off x="457200" y="274320"/>
-            <a:ext cx="7132320" cy="914400"/>
+            <a:ext cx="6400800" cy="914400"/>
           </a:xfrm>
           <a:prstGeom prst="rect">
             <a:avLst/>
@@ -4509,7 +4509,7 @@
         <p:spPr>
           <a:xfrm>
             <a:off x="457200" y="274320"/>
-            <a:ext cx="7132320" cy="914400"/>
+            <a:ext cx="6400800" cy="914400"/>
           </a:xfrm>
           <a:prstGeom prst="rect">
             <a:avLst/>
@@ -4599,7 +4599,7 @@
         <p:spPr>
           <a:xfrm>
             <a:off x="457200" y="274320"/>
-            <a:ext cx="7132320" cy="914400"/>
+            <a:ext cx="6400800" cy="914400"/>
           </a:xfrm>
           <a:prstGeom prst="rect">
             <a:avLst/>
@@ -4773,7 +4773,7 @@
         <p:spPr>
           <a:xfrm>
             <a:off x="457200" y="274320"/>
-            <a:ext cx="7132320" cy="914400"/>
+            <a:ext cx="6400800" cy="914400"/>
           </a:xfrm>
           <a:prstGeom prst="rect">
             <a:avLst/>
@@ -4863,7 +4863,7 @@
         <p:spPr>
           <a:xfrm>
             <a:off x="457200" y="274320"/>
-            <a:ext cx="7132320" cy="914400"/>
+            <a:ext cx="6400800" cy="914400"/>
           </a:xfrm>
           <a:prstGeom prst="rect">
             <a:avLst/>
@@ -4983,7 +4983,7 @@
         <p:spPr>
           <a:xfrm>
             <a:off x="457200" y="274320"/>
-            <a:ext cx="7132320" cy="914400"/>
+            <a:ext cx="6400800" cy="914400"/>
           </a:xfrm>
           <a:prstGeom prst="rect">
             <a:avLst/>
@@ -5073,7 +5073,7 @@
         <p:spPr>
           <a:xfrm>
             <a:off x="457200" y="274320"/>
-            <a:ext cx="7132320" cy="914400"/>
+            <a:ext cx="6400800" cy="914400"/>
           </a:xfrm>
           <a:prstGeom prst="rect">
             <a:avLst/>
@@ -5407,7 +5407,7 @@
         <p:spPr>
           <a:xfrm>
             <a:off x="457200" y="274320"/>
-            <a:ext cx="7132320" cy="914400"/>
+            <a:ext cx="6400800" cy="914400"/>
           </a:xfrm>
           <a:prstGeom prst="rect">
             <a:avLst/>
@@ -5497,7 +5497,7 @@
         <p:spPr>
           <a:xfrm>
             <a:off x="457200" y="274320"/>
-            <a:ext cx="7132320" cy="914400"/>
+            <a:ext cx="6400800" cy="914400"/>
           </a:xfrm>
           <a:prstGeom prst="rect">
             <a:avLst/>
@@ -5652,7 +5652,7 @@
         <p:spPr>
           <a:xfrm>
             <a:off x="457200" y="274320"/>
-            <a:ext cx="7132320" cy="914400"/>
+            <a:ext cx="6400800" cy="914400"/>
           </a:xfrm>
           <a:prstGeom prst="rect">
             <a:avLst/>
@@ -5742,7 +5742,7 @@
         <p:spPr>
           <a:xfrm>
             <a:off x="457200" y="274320"/>
-            <a:ext cx="7132320" cy="914400"/>
+            <a:ext cx="6400800" cy="914400"/>
           </a:xfrm>
           <a:prstGeom prst="rect">
             <a:avLst/>
@@ -5862,7 +5862,7 @@
         <p:spPr>
           <a:xfrm>
             <a:off x="457200" y="274320"/>
-            <a:ext cx="7132320" cy="914400"/>
+            <a:ext cx="6400800" cy="914400"/>
           </a:xfrm>
           <a:prstGeom prst="rect">
             <a:avLst/>
@@ -5952,7 +5952,7 @@
         <p:spPr>
           <a:xfrm>
             <a:off x="457200" y="274320"/>
-            <a:ext cx="7132320" cy="914400"/>
+            <a:ext cx="6400800" cy="914400"/>
           </a:xfrm>
           <a:prstGeom prst="rect">
             <a:avLst/>
@@ -6054,7 +6054,7 @@
         <p:spPr>
           <a:xfrm>
             <a:off x="457200" y="274320"/>
-            <a:ext cx="7132320" cy="914400"/>
+            <a:ext cx="6400800" cy="914400"/>
           </a:xfrm>
           <a:prstGeom prst="rect">
             <a:avLst/>
@@ -6144,7 +6144,7 @@
         <p:spPr>
           <a:xfrm>
             <a:off x="457200" y="274320"/>
-            <a:ext cx="7132320" cy="914400"/>
+            <a:ext cx="6400800" cy="914400"/>
           </a:xfrm>
           <a:prstGeom prst="rect">
             <a:avLst/>
@@ -6246,7 +6246,7 @@
         <p:spPr>
           <a:xfrm>
             <a:off x="457200" y="274320"/>
-            <a:ext cx="7132320" cy="914400"/>
+            <a:ext cx="6400800" cy="914400"/>
           </a:xfrm>
           <a:prstGeom prst="rect">
             <a:avLst/>
@@ -6336,7 +6336,7 @@
         <p:spPr>
           <a:xfrm>
             <a:off x="457200" y="274320"/>
-            <a:ext cx="7132320" cy="914400"/>
+            <a:ext cx="6400800" cy="914400"/>
           </a:xfrm>
           <a:prstGeom prst="rect">
             <a:avLst/>
@@ -6438,7 +6438,7 @@
         <p:spPr>
           <a:xfrm>
             <a:off x="457200" y="274320"/>
-            <a:ext cx="7132320" cy="914400"/>
+            <a:ext cx="6400800" cy="914400"/>
           </a:xfrm>
           <a:prstGeom prst="rect">
             <a:avLst/>
@@ -6528,7 +6528,7 @@
         <p:spPr>
           <a:xfrm>
             <a:off x="457200" y="274320"/>
-            <a:ext cx="7132320" cy="914400"/>
+            <a:ext cx="6400800" cy="914400"/>
           </a:xfrm>
           <a:prstGeom prst="rect">
             <a:avLst/>
@@ -6740,7 +6740,7 @@
         <p:spPr>
           <a:xfrm>
             <a:off x="457200" y="274320"/>
-            <a:ext cx="7132320" cy="914400"/>
+            <a:ext cx="6400800" cy="914400"/>
           </a:xfrm>
           <a:prstGeom prst="rect">
             <a:avLst/>
@@ -6830,7 +6830,7 @@
         <p:spPr>
           <a:xfrm>
             <a:off x="457200" y="274320"/>
-            <a:ext cx="7132320" cy="914400"/>
+            <a:ext cx="6400800" cy="914400"/>
           </a:xfrm>
           <a:prstGeom prst="rect">
             <a:avLst/>
@@ -6932,7 +6932,7 @@
         <p:spPr>
           <a:xfrm>
             <a:off x="457200" y="274320"/>
-            <a:ext cx="7132320" cy="914400"/>
+            <a:ext cx="6400800" cy="914400"/>
           </a:xfrm>
           <a:prstGeom prst="rect">
             <a:avLst/>
@@ -7022,7 +7022,7 @@
         <p:spPr>
           <a:xfrm>
             <a:off x="457200" y="274320"/>
-            <a:ext cx="7132320" cy="914400"/>
+            <a:ext cx="6400800" cy="914400"/>
           </a:xfrm>
           <a:prstGeom prst="rect">
             <a:avLst/>
@@ -7142,7 +7142,7 @@
         <p:spPr>
           <a:xfrm>
             <a:off x="457200" y="274320"/>
-            <a:ext cx="7132320" cy="914400"/>
+            <a:ext cx="6400800" cy="914400"/>
           </a:xfrm>
           <a:prstGeom prst="rect">
             <a:avLst/>
@@ -7232,7 +7232,7 @@
         <p:spPr>
           <a:xfrm>
             <a:off x="457200" y="274320"/>
-            <a:ext cx="7132320" cy="914400"/>
+            <a:ext cx="6400800" cy="914400"/>
           </a:xfrm>
           <a:prstGeom prst="rect">
             <a:avLst/>
@@ -7536,7 +7536,7 @@
         <p:spPr>
           <a:xfrm>
             <a:off x="457200" y="274320"/>
-            <a:ext cx="7132320" cy="914400"/>
+            <a:ext cx="6400800" cy="914400"/>
           </a:xfrm>
           <a:prstGeom prst="rect">
             <a:avLst/>
@@ -7626,7 +7626,7 @@
         <p:spPr>
           <a:xfrm>
             <a:off x="457200" y="274320"/>
-            <a:ext cx="7132320" cy="914400"/>
+            <a:ext cx="6400800" cy="914400"/>
           </a:xfrm>
           <a:prstGeom prst="rect">
             <a:avLst/>
@@ -7838,7 +7838,7 @@
         <p:spPr>
           <a:xfrm>
             <a:off x="457200" y="274320"/>
-            <a:ext cx="7132320" cy="914400"/>
+            <a:ext cx="6400800" cy="914400"/>
           </a:xfrm>
           <a:prstGeom prst="rect">
             <a:avLst/>
@@ -7928,7 +7928,7 @@
         <p:spPr>
           <a:xfrm>
             <a:off x="457200" y="274320"/>
-            <a:ext cx="7132320" cy="914400"/>
+            <a:ext cx="6400800" cy="914400"/>
           </a:xfrm>
           <a:prstGeom prst="rect">
             <a:avLst/>
@@ -8302,7 +8302,7 @@
         <p:spPr>
           <a:xfrm>
             <a:off x="457200" y="274320"/>
-            <a:ext cx="7132320" cy="914400"/>
+            <a:ext cx="6400800" cy="914400"/>
           </a:xfrm>
           <a:prstGeom prst="rect">
             <a:avLst/>
@@ -8392,7 +8392,7 @@
         <p:spPr>
           <a:xfrm>
             <a:off x="457200" y="274320"/>
-            <a:ext cx="7132320" cy="914400"/>
+            <a:ext cx="6400800" cy="914400"/>
           </a:xfrm>
           <a:prstGeom prst="rect">
             <a:avLst/>
@@ -8760,7 +8760,7 @@
         <p:spPr>
           <a:xfrm>
             <a:off x="457200" y="274320"/>
-            <a:ext cx="7132320" cy="914400"/>
+            <a:ext cx="6400800" cy="914400"/>
           </a:xfrm>
           <a:prstGeom prst="rect">
             <a:avLst/>
@@ -8850,7 +8850,7 @@
         <p:spPr>
           <a:xfrm>
             <a:off x="457200" y="274320"/>
-            <a:ext cx="7132320" cy="914400"/>
+            <a:ext cx="6400800" cy="914400"/>
           </a:xfrm>
           <a:prstGeom prst="rect">
             <a:avLst/>
@@ -8952,7 +8952,7 @@
         <p:spPr>
           <a:xfrm>
             <a:off x="457200" y="274320"/>
-            <a:ext cx="7132320" cy="914400"/>
+            <a:ext cx="6400800" cy="914400"/>
           </a:xfrm>
           <a:prstGeom prst="rect">
             <a:avLst/>
@@ -9042,7 +9042,7 @@
         <p:spPr>
           <a:xfrm>
             <a:off x="457200" y="274320"/>
-            <a:ext cx="7132320" cy="914400"/>
+            <a:ext cx="6400800" cy="914400"/>
           </a:xfrm>
           <a:prstGeom prst="rect">
             <a:avLst/>
@@ -9162,7 +9162,7 @@
         <p:spPr>
           <a:xfrm>
             <a:off x="457200" y="274320"/>
-            <a:ext cx="7132320" cy="914400"/>
+            <a:ext cx="6400800" cy="914400"/>
           </a:xfrm>
           <a:prstGeom prst="rect">
             <a:avLst/>
@@ -9252,7 +9252,7 @@
         <p:spPr>
           <a:xfrm>
             <a:off x="457200" y="274320"/>
-            <a:ext cx="7132320" cy="914400"/>
+            <a:ext cx="6400800" cy="914400"/>
           </a:xfrm>
           <a:prstGeom prst="rect">
             <a:avLst/>
@@ -9372,7 +9372,7 @@
         <p:spPr>
           <a:xfrm>
             <a:off x="457200" y="274320"/>
-            <a:ext cx="7132320" cy="914400"/>
+            <a:ext cx="6400800" cy="914400"/>
           </a:xfrm>
           <a:prstGeom prst="rect">
             <a:avLst/>
@@ -9462,7 +9462,7 @@
         <p:spPr>
           <a:xfrm>
             <a:off x="457200" y="274320"/>
-            <a:ext cx="7132320" cy="914400"/>
+            <a:ext cx="6400800" cy="914400"/>
           </a:xfrm>
           <a:prstGeom prst="rect">
             <a:avLst/>
@@ -9617,7 +9617,7 @@
         <p:spPr>
           <a:xfrm>
             <a:off x="457200" y="274320"/>
-            <a:ext cx="7132320" cy="914400"/>
+            <a:ext cx="6400800" cy="914400"/>
           </a:xfrm>
           <a:prstGeom prst="rect">
             <a:avLst/>
@@ -9707,7 +9707,7 @@
         <p:spPr>
           <a:xfrm>
             <a:off x="457200" y="274320"/>
-            <a:ext cx="7132320" cy="914400"/>
+            <a:ext cx="6400800" cy="914400"/>
           </a:xfrm>
           <a:prstGeom prst="rect">
             <a:avLst/>
@@ -9973,7 +9973,7 @@
         <p:spPr>
           <a:xfrm>
             <a:off x="457200" y="274320"/>
-            <a:ext cx="7132320" cy="914400"/>
+            <a:ext cx="6400800" cy="914400"/>
           </a:xfrm>
           <a:prstGeom prst="rect">
             <a:avLst/>
@@ -10063,7 +10063,7 @@
         <p:spPr>
           <a:xfrm>
             <a:off x="457200" y="274320"/>
-            <a:ext cx="7132320" cy="914400"/>
+            <a:ext cx="6400800" cy="914400"/>
           </a:xfrm>
           <a:prstGeom prst="rect">
             <a:avLst/>
@@ -10218,7 +10218,7 @@
         <p:spPr>
           <a:xfrm>
             <a:off x="457200" y="274320"/>
-            <a:ext cx="7132320" cy="914400"/>
+            <a:ext cx="6400800" cy="914400"/>
           </a:xfrm>
           <a:prstGeom prst="rect">
             <a:avLst/>
@@ -10308,7 +10308,7 @@
         <p:spPr>
           <a:xfrm>
             <a:off x="457200" y="274320"/>
-            <a:ext cx="7132320" cy="914400"/>
+            <a:ext cx="6400800" cy="914400"/>
           </a:xfrm>
           <a:prstGeom prst="rect">
             <a:avLst/>
@@ -10805,7 +10805,7 @@
         <p:spPr>
           <a:xfrm>
             <a:off x="457200" y="274320"/>
-            <a:ext cx="7132320" cy="914400"/>
+            <a:ext cx="6400800" cy="914400"/>
           </a:xfrm>
           <a:prstGeom prst="rect">
             <a:avLst/>
@@ -10895,7 +10895,7 @@
         <p:spPr>
           <a:xfrm>
             <a:off x="457200" y="274320"/>
-            <a:ext cx="7132320" cy="914400"/>
+            <a:ext cx="6400800" cy="914400"/>
           </a:xfrm>
           <a:prstGeom prst="rect">
             <a:avLst/>
@@ -11050,7 +11050,7 @@
         <p:spPr>
           <a:xfrm>
             <a:off x="457200" y="274320"/>
-            <a:ext cx="7132320" cy="914400"/>
+            <a:ext cx="6400800" cy="914400"/>
           </a:xfrm>
           <a:prstGeom prst="rect">
             <a:avLst/>
@@ -11140,7 +11140,7 @@
         <p:spPr>
           <a:xfrm>
             <a:off x="457200" y="274320"/>
-            <a:ext cx="7132320" cy="914400"/>
+            <a:ext cx="6400800" cy="914400"/>
           </a:xfrm>
           <a:prstGeom prst="rect">
             <a:avLst/>
@@ -11260,7 +11260,7 @@
         <p:spPr>
           <a:xfrm>
             <a:off x="457200" y="274320"/>
-            <a:ext cx="7132320" cy="914400"/>
+            <a:ext cx="6400800" cy="914400"/>
           </a:xfrm>
           <a:prstGeom prst="rect">
             <a:avLst/>
@@ -11350,7 +11350,7 @@
         <p:spPr>
           <a:xfrm>
             <a:off x="457200" y="274320"/>
-            <a:ext cx="7132320" cy="914400"/>
+            <a:ext cx="6400800" cy="914400"/>
           </a:xfrm>
           <a:prstGeom prst="rect">
             <a:avLst/>
@@ -11600,7 +11600,7 @@
         <p:spPr>
           <a:xfrm>
             <a:off x="457200" y="274320"/>
-            <a:ext cx="7132320" cy="914400"/>
+            <a:ext cx="6400800" cy="914400"/>
           </a:xfrm>
           <a:prstGeom prst="rect">
             <a:avLst/>
@@ -11690,7 +11690,7 @@
         <p:spPr>
           <a:xfrm>
             <a:off x="457200" y="274320"/>
-            <a:ext cx="7132320" cy="914400"/>
+            <a:ext cx="6400800" cy="914400"/>
           </a:xfrm>
           <a:prstGeom prst="rect">
             <a:avLst/>
@@ -13177,7 +13177,7 @@
         <p:spPr>
           <a:xfrm>
             <a:off x="457200" y="274320"/>
-            <a:ext cx="7132320" cy="914400"/>
+            <a:ext cx="6400800" cy="914400"/>
           </a:xfrm>
           <a:prstGeom prst="rect">
             <a:avLst/>
@@ -13267,7 +13267,7 @@
         <p:spPr>
           <a:xfrm>
             <a:off x="457200" y="274320"/>
-            <a:ext cx="7132320" cy="914400"/>
+            <a:ext cx="6400800" cy="914400"/>
           </a:xfrm>
           <a:prstGeom prst="rect">
             <a:avLst/>
@@ -13460,7 +13460,7 @@
         <p:spPr>
           <a:xfrm>
             <a:off x="457200" y="274320"/>
-            <a:ext cx="7132320" cy="914400"/>
+            <a:ext cx="6400800" cy="914400"/>
           </a:xfrm>
           <a:prstGeom prst="rect">
             <a:avLst/>
@@ -13550,7 +13550,7 @@
         <p:spPr>
           <a:xfrm>
             <a:off x="457200" y="274320"/>
-            <a:ext cx="7132320" cy="914400"/>
+            <a:ext cx="6400800" cy="914400"/>
           </a:xfrm>
           <a:prstGeom prst="rect">
             <a:avLst/>
@@ -13838,7 +13838,7 @@
         <p:spPr>
           <a:xfrm>
             <a:off x="457200" y="274320"/>
-            <a:ext cx="7132320" cy="914400"/>
+            <a:ext cx="6400800" cy="914400"/>
           </a:xfrm>
           <a:prstGeom prst="rect">
             <a:avLst/>
@@ -13928,7 +13928,7 @@
         <p:spPr>
           <a:xfrm>
             <a:off x="457200" y="274320"/>
-            <a:ext cx="7132320" cy="914400"/>
+            <a:ext cx="6400800" cy="914400"/>
           </a:xfrm>
           <a:prstGeom prst="rect">
             <a:avLst/>
@@ -14325,7 +14325,7 @@
         <p:spPr>
           <a:xfrm>
             <a:off x="457200" y="274320"/>
-            <a:ext cx="7132320" cy="914400"/>
+            <a:ext cx="6400800" cy="914400"/>
           </a:xfrm>
           <a:prstGeom prst="rect">
             <a:avLst/>
@@ -14415,7 +14415,7 @@
         <p:spPr>
           <a:xfrm>
             <a:off x="457200" y="274320"/>
-            <a:ext cx="7132320" cy="914400"/>
+            <a:ext cx="6400800" cy="914400"/>
           </a:xfrm>
           <a:prstGeom prst="rect">
             <a:avLst/>
@@ -15984,7 +15984,7 @@
         <p:spPr>
           <a:xfrm>
             <a:off x="457200" y="274320"/>
-            <a:ext cx="7132320" cy="914400"/>
+            <a:ext cx="6400800" cy="914400"/>
           </a:xfrm>
           <a:prstGeom prst="rect">
             <a:avLst/>
@@ -16074,7 +16074,7 @@
         <p:spPr>
           <a:xfrm>
             <a:off x="457200" y="274320"/>
-            <a:ext cx="7132320" cy="914400"/>
+            <a:ext cx="6400800" cy="914400"/>
           </a:xfrm>
           <a:prstGeom prst="rect">
             <a:avLst/>
@@ -16359,7 +16359,7 @@
         <p:spPr>
           <a:xfrm>
             <a:off x="457200" y="274320"/>
-            <a:ext cx="7132320" cy="914400"/>
+            <a:ext cx="6400800" cy="914400"/>
           </a:xfrm>
           <a:prstGeom prst="rect">
             <a:avLst/>
@@ -16449,7 +16449,7 @@
         <p:spPr>
           <a:xfrm>
             <a:off x="457200" y="274320"/>
-            <a:ext cx="7132320" cy="914400"/>
+            <a:ext cx="6400800" cy="914400"/>
           </a:xfrm>
           <a:prstGeom prst="rect">
             <a:avLst/>
@@ -16972,7 +16972,7 @@
         <p:spPr>
           <a:xfrm>
             <a:off x="457200" y="274320"/>
-            <a:ext cx="7132320" cy="914400"/>
+            <a:ext cx="6400800" cy="914400"/>
           </a:xfrm>
           <a:prstGeom prst="rect">
             <a:avLst/>
@@ -17062,7 +17062,7 @@
         <p:spPr>
           <a:xfrm>
             <a:off x="457200" y="274320"/>
-            <a:ext cx="7132320" cy="914400"/>
+            <a:ext cx="6400800" cy="914400"/>
           </a:xfrm>
           <a:prstGeom prst="rect">
             <a:avLst/>
@@ -18516,7 +18516,7 @@
         <p:spPr>
           <a:xfrm>
             <a:off x="457200" y="274320"/>
-            <a:ext cx="7132320" cy="914400"/>
+            <a:ext cx="6400800" cy="914400"/>
           </a:xfrm>
           <a:prstGeom prst="rect">
             <a:avLst/>
@@ -18606,7 +18606,7 @@
         <p:spPr>
           <a:xfrm>
             <a:off x="457200" y="274320"/>
-            <a:ext cx="7132320" cy="914400"/>
+            <a:ext cx="6400800" cy="914400"/>
           </a:xfrm>
           <a:prstGeom prst="rect">
             <a:avLst/>
@@ -18708,7 +18708,7 @@
         <p:spPr>
           <a:xfrm>
             <a:off x="457200" y="274320"/>
-            <a:ext cx="7132320" cy="914400"/>
+            <a:ext cx="6400800" cy="914400"/>
           </a:xfrm>
           <a:prstGeom prst="rect">
             <a:avLst/>
@@ -18798,7 +18798,7 @@
         <p:spPr>
           <a:xfrm>
             <a:off x="457200" y="274320"/>
-            <a:ext cx="7132320" cy="914400"/>
+            <a:ext cx="6400800" cy="914400"/>
           </a:xfrm>
           <a:prstGeom prst="rect">
             <a:avLst/>
@@ -18900,7 +18900,7 @@
         <p:spPr>
           <a:xfrm>
             <a:off x="457200" y="274320"/>
-            <a:ext cx="7132320" cy="914400"/>
+            <a:ext cx="6400800" cy="914400"/>
           </a:xfrm>
           <a:prstGeom prst="rect">
             <a:avLst/>
@@ -18990,7 +18990,7 @@
         <p:spPr>
           <a:xfrm>
             <a:off x="457200" y="274320"/>
-            <a:ext cx="7132320" cy="914400"/>
+            <a:ext cx="6400800" cy="914400"/>
           </a:xfrm>
           <a:prstGeom prst="rect">
             <a:avLst/>
@@ -19092,7 +19092,7 @@
         <p:spPr>
           <a:xfrm>
             <a:off x="457200" y="274320"/>
-            <a:ext cx="7132320" cy="914400"/>
+            <a:ext cx="6400800" cy="914400"/>
           </a:xfrm>
           <a:prstGeom prst="rect">
             <a:avLst/>
@@ -19182,7 +19182,7 @@
         <p:spPr>
           <a:xfrm>
             <a:off x="457200" y="274320"/>
-            <a:ext cx="7132320" cy="914400"/>
+            <a:ext cx="6400800" cy="914400"/>
           </a:xfrm>
           <a:prstGeom prst="rect">
             <a:avLst/>
@@ -20208,7 +20208,7 @@
         <p:spPr>
           <a:xfrm>
             <a:off x="457200" y="274320"/>
-            <a:ext cx="7132320" cy="914400"/>
+            <a:ext cx="6400800" cy="914400"/>
           </a:xfrm>
           <a:prstGeom prst="rect">
             <a:avLst/>
@@ -20298,7 +20298,7 @@
         <p:spPr>
           <a:xfrm>
             <a:off x="457200" y="274320"/>
-            <a:ext cx="7132320" cy="914400"/>
+            <a:ext cx="6400800" cy="914400"/>
           </a:xfrm>
           <a:prstGeom prst="rect">
             <a:avLst/>
@@ -20453,7 +20453,7 @@
         <p:spPr>
           <a:xfrm>
             <a:off x="457200" y="274320"/>
-            <a:ext cx="7132320" cy="914400"/>
+            <a:ext cx="6400800" cy="914400"/>
           </a:xfrm>
           <a:prstGeom prst="rect">
             <a:avLst/>
@@ -20543,7 +20543,7 @@
         <p:spPr>
           <a:xfrm>
             <a:off x="457200" y="274320"/>
-            <a:ext cx="7132320" cy="914400"/>
+            <a:ext cx="6400800" cy="914400"/>
           </a:xfrm>
           <a:prstGeom prst="rect">
             <a:avLst/>
@@ -20645,7 +20645,7 @@
         <p:spPr>
           <a:xfrm>
             <a:off x="457200" y="274320"/>
-            <a:ext cx="7132320" cy="914400"/>
+            <a:ext cx="6400800" cy="914400"/>
           </a:xfrm>
           <a:prstGeom prst="rect">
             <a:avLst/>
@@ -20735,7 +20735,7 @@
         <p:spPr>
           <a:xfrm>
             <a:off x="457200" y="274320"/>
-            <a:ext cx="7132320" cy="914400"/>
+            <a:ext cx="6400800" cy="914400"/>
           </a:xfrm>
           <a:prstGeom prst="rect">
             <a:avLst/>
@@ -21100,7 +21100,7 @@
         <p:spPr>
           <a:xfrm>
             <a:off x="457200" y="274320"/>
-            <a:ext cx="7132320" cy="914400"/>
+            <a:ext cx="6400800" cy="914400"/>
           </a:xfrm>
           <a:prstGeom prst="rect">
             <a:avLst/>
@@ -21190,7 +21190,7 @@
         <p:spPr>
           <a:xfrm>
             <a:off x="457200" y="274320"/>
-            <a:ext cx="7132320" cy="914400"/>
+            <a:ext cx="6400800" cy="914400"/>
           </a:xfrm>
           <a:prstGeom prst="rect">
             <a:avLst/>
@@ -22889,7 +22889,7 @@
         <p:spPr>
           <a:xfrm>
             <a:off x="457200" y="274320"/>
-            <a:ext cx="7132320" cy="914400"/>
+            <a:ext cx="6400800" cy="914400"/>
           </a:xfrm>
           <a:prstGeom prst="rect">
             <a:avLst/>
@@ -22979,7 +22979,7 @@
         <p:spPr>
           <a:xfrm>
             <a:off x="457200" y="274320"/>
-            <a:ext cx="7132320" cy="914400"/>
+            <a:ext cx="6400800" cy="914400"/>
           </a:xfrm>
           <a:prstGeom prst="rect">
             <a:avLst/>
@@ -23169,7 +23169,7 @@
         <p:spPr>
           <a:xfrm>
             <a:off x="457200" y="274320"/>
-            <a:ext cx="7132320" cy="914400"/>
+            <a:ext cx="6400800" cy="914400"/>
           </a:xfrm>
           <a:prstGeom prst="rect">
             <a:avLst/>
@@ -23259,7 +23259,7 @@
         <p:spPr>
           <a:xfrm>
             <a:off x="457200" y="274320"/>
-            <a:ext cx="7132320" cy="914400"/>
+            <a:ext cx="6400800" cy="914400"/>
           </a:xfrm>
           <a:prstGeom prst="rect">
             <a:avLst/>
@@ -23361,7 +23361,7 @@
         <p:spPr>
           <a:xfrm>
             <a:off x="457200" y="274320"/>
-            <a:ext cx="7132320" cy="914400"/>
+            <a:ext cx="6400800" cy="914400"/>
           </a:xfrm>
           <a:prstGeom prst="rect">
             <a:avLst/>
@@ -23451,7 +23451,7 @@
         <p:spPr>
           <a:xfrm>
             <a:off x="457200" y="274320"/>
-            <a:ext cx="7132320" cy="914400"/>
+            <a:ext cx="6400800" cy="914400"/>
           </a:xfrm>
           <a:prstGeom prst="rect">
             <a:avLst/>
@@ -23606,7 +23606,7 @@
         <p:spPr>
           <a:xfrm>
             <a:off x="457200" y="274320"/>
-            <a:ext cx="7132320" cy="914400"/>
+            <a:ext cx="6400800" cy="914400"/>
           </a:xfrm>
           <a:prstGeom prst="rect">
             <a:avLst/>
@@ -23696,7 +23696,7 @@
         <p:spPr>
           <a:xfrm>
             <a:off x="457200" y="274320"/>
-            <a:ext cx="7132320" cy="914400"/>
+            <a:ext cx="6400800" cy="914400"/>
           </a:xfrm>
           <a:prstGeom prst="rect">
             <a:avLst/>

</xml_diff>